<commit_message>
Workshop 4: single Colab notebook on the OpenAI API + pip-installable debtbuster
Co-Authored-By: Claude Opus 5 <noreply@anthropic.com>
</commit_message>
<xml_diff>
--- a/LLMA4SE_Workshop4_Slides.pptx
+++ b/LLMA4SE_Workshop4_Slides.pptx
@@ -7,6 +7,7 @@
   <p:sldIdLst>
     <p:sldId id="256" r:id="rId2"/>
     <p:sldId id="257" r:id="rId3"/>
+    <p:sldId id="274" r:id="rId25"/>
     <p:sldId id="258" r:id="rId4"/>
     <p:sldId id="259" r:id="rId5"/>
     <p:sldId id="260" r:id="rId6"/>
@@ -2520,7 +2521,7 @@
                 <a:ea typeface="Calibri" pitchFamily="34" charset="-122"/>
                 <a:cs typeface="Calibri" pitchFamily="34" charset="-120"/>
               </a:rPr>
-              <a:t>Hands-on: anti-pattern detection, code smell &amp; technical debt resolution — on a free GPU</a:t>
+              <a:t>Hands-on: anti-pattern detection, code smell &amp; technical debt resolution — one notebook, one API key</a:t>
             </a:r>
             <a:endParaRPr lang="en-US" sz="1700" dirty="0"/>
           </a:p>
@@ -2718,7 +2719,7 @@
                 <a:ea typeface="Courier New" pitchFamily="34" charset="-122"/>
                 <a:cs typeface="Courier New" pitchFamily="34" charset="-120"/>
               </a:rPr>
-              <a:t>GOOGLE COLAB · T4</a:t>
+              <a:t>COLAB · OPENAI API</a:t>
             </a:r>
             <a:endParaRPr lang="en-US" sz="1050" dirty="0"/>
           </a:p>
@@ -5912,7 +5913,7 @@
                 <a:ea typeface="Courier New" pitchFamily="34" charset="-122"/>
                 <a:cs typeface="Courier New" pitchFamily="34" charset="-120"/>
               </a:rPr>
-              <a:t>HANDS-ON · NOTEBOOK PART 2</a:t>
+              <a:t>HANDS-ON · PART 2</a:t>
             </a:r>
             <a:endParaRPr lang="en-US" sz="1300" dirty="0"/>
           </a:p>
@@ -6945,7 +6946,7 @@
                 <a:ea typeface="Courier New" pitchFamily="34" charset="-122"/>
                 <a:cs typeface="Courier New" pitchFamily="34" charset="-120"/>
               </a:rPr>
-              <a:t>HANDS-ON · NOTEBOOK PART 3</a:t>
+              <a:t>HANDS-ON · PART 3</a:t>
             </a:r>
             <a:endParaRPr lang="en-US" sz="1300" dirty="0"/>
           </a:p>
@@ -7156,7 +7157,7 @@
                 <a:ea typeface="Courier New" pitchFamily="34" charset="-122"/>
                 <a:cs typeface="Courier New" pitchFamily="34" charset="-120"/>
               </a:rPr>
-              <a:t>~45 MINUTES</a:t>
+              <a:t>~40 MINUTES</a:t>
             </a:r>
             <a:endParaRPr lang="en-US" sz="1050" dirty="0"/>
           </a:p>
@@ -7483,7 +7484,7 @@
                 <a:ea typeface="Calibri" pitchFamily="34" charset="-122"/>
                 <a:cs typeface="Calibri" pitchFamily="34" charset="-120"/>
               </a:rPr>
-              <a:t>transformers in-process</a:t>
+              <a:t>a raw API call per agent</a:t>
             </a:r>
             <a:endParaRPr lang="en-US" sz="1150" dirty="0"/>
           </a:p>
@@ -7595,7 +7596,7 @@
                 <a:ea typeface="Cambria" pitchFamily="34" charset="-122"/>
                 <a:cs typeface="Cambria" pitchFamily="34" charset="-120"/>
               </a:rPr>
-              <a:t>Ollama  </a:t>
+              <a:t>one llm() helper  </a:t>
             </a:r>
             <a:pPr indent="0" marL="0">
               <a:buNone/>
@@ -7609,7 +7610,7 @@
                 <a:ea typeface="Calibri" pitchFamily="34" charset="-122"/>
                 <a:cs typeface="Calibri" pitchFamily="34" charset="-120"/>
               </a:rPr>
-              <a:t>a local model server: 7B @ 4-bit on the same T4, one model → many agents</a:t>
+              <a:t>one client, six agents — swap gpt-4.1-mini for a gpt-5 reasoning model in one line</a:t>
             </a:r>
             <a:endParaRPr lang="en-US" sz="1300" dirty="0"/>
           </a:p>
@@ -8352,7 +8353,7 @@
                 <a:ea typeface="Courier New" pitchFamily="34" charset="-122"/>
                 <a:cs typeface="Courier New" pitchFamily="34" charset="-120"/>
               </a:rPr>
-              <a:t>HANDS-ON · NOTEBOOK PART 4</a:t>
+              <a:t>HANDS-ON · PART 4 · TAKE-HOME</a:t>
             </a:r>
             <a:endParaRPr lang="en-US" sz="1300" dirty="0"/>
           </a:p>
@@ -8391,7 +8392,7 @@
                 <a:ea typeface="Cambria" pitchFamily="34" charset="-122"/>
                 <a:cs typeface="Cambria" pitchFamily="34" charset="-120"/>
               </a:rPr>
-              <a:t>Ollama · LangGraph · Deep Agents</a:t>
+              <a:t>LangGraph · Deep Agents · debtbuster</a:t>
             </a:r>
             <a:endParaRPr lang="en-US" sz="3600" dirty="0"/>
           </a:p>
@@ -8434,7 +8435,7 @@
                 <a:ea typeface="Calibri" pitchFamily="34" charset="-122"/>
                 <a:cs typeface="Calibri" pitchFamily="34" charset="-120"/>
               </a:rPr>
-              <a:t>Install Ollama on Colab, pull qwen2.5-coder:7b (4-bit) — a stronger brain, same T4</a:t>
+              <a:t>The same QA gates, three different frameworks — and they never change a byte</a:t>
             </a:r>
             <a:endParaRPr lang="en-US" sz="1550" dirty="0"/>
           </a:p>
@@ -8563,7 +8564,7 @@
                 <a:ea typeface="Courier New" pitchFamily="34" charset="-122"/>
                 <a:cs typeface="Courier New" pitchFamily="34" charset="-120"/>
               </a:rPr>
-              <a:t>~60 MINUTES</a:t>
+              <a:t>~50 MINUTES · SELF-PACED</a:t>
             </a:r>
             <a:endParaRPr lang="en-US" sz="1050" dirty="0"/>
           </a:p>
@@ -8739,7 +8740,7 @@
                 <a:ea typeface="Cambria" pitchFamily="34" charset="-122"/>
                 <a:cs typeface="Cambria" pitchFamily="34" charset="-120"/>
               </a:rPr>
-              <a:t>A verified, cooperative agent pipeline — on a free GPU</a:t>
+              <a:t>A verified, cooperative agent pipeline — in one notebook</a:t>
             </a:r>
             <a:endParaRPr lang="en-US" sz="2800" dirty="0"/>
           </a:p>
@@ -8992,7 +8993,7 @@
                 <a:ea typeface="Calibri" pitchFamily="34" charset="-122"/>
                 <a:cs typeface="Calibri" pitchFamily="34" charset="-120"/>
               </a:rPr>
-              <a:t>Verification gates make small models useful  </a:t>
+              <a:t>Verification is what earns the trust  </a:t>
             </a:r>
             <a:pPr indent="0" marL="0">
               <a:buNone/>
@@ -9213,6 +9214,1023 @@
               <a:t>Karthik Shivashankar · karthik13sankar@outlook.com  ·  Adela Nedisan Videsjorden  ·  LLMA4SE 2026</a:t>
             </a:r>
             <a:endParaRPr lang="en-US" sz="1050" dirty="0"/>
+          </a:p>
+        </p:txBody>
+      </p:sp>
+    </p:spTree>
+  </p:cSld>
+  <p:clrMapOvr>
+    <a:masterClrMapping/>
+  </p:clrMapOvr>
+</p:sld>
+</file>
+
+<file path=ppt/slides/slide19.xml><?xml version="1.0" encoding="utf-8"?>
+<p:sld xmlns:a="http://schemas.openxmlformats.org/drawingml/2006/main" xmlns:r="http://schemas.openxmlformats.org/officeDocument/2006/relationships" xmlns:p="http://schemas.openxmlformats.org/presentationml/2006/main">
+  <p:cSld name="Slide 5">
+    <p:bg>
+      <p:bgPr>
+        <a:solidFill>
+          <a:srgbClr val="FFFFFF"/>
+        </a:solidFill>
+      </p:bgPr>
+    </p:bg>
+    <p:spTree>
+      <p:nvGrpSpPr>
+        <p:cNvPr id="1" name=""/>
+        <p:cNvGrpSpPr/>
+        <p:nvPr/>
+      </p:nvGrpSpPr>
+      <p:grpSpPr>
+        <a:xfrm>
+          <a:off x="0" y="0"/>
+          <a:ext cx="0" cy="0"/>
+          <a:chOff x="0" y="0"/>
+          <a:chExt cx="0" cy="0"/>
+        </a:xfrm>
+      </p:grpSpPr>
+      <p:sp>
+        <p:nvSpPr>
+          <p:cNvPr id="2" name="Text 0"/>
+          <p:cNvSpPr/>
+          <p:nvPr/>
+        </p:nvSpPr>
+        <p:spPr>
+          <a:xfrm>
+            <a:off x="502920" y="274320"/>
+            <a:ext cx="8138160" cy="274320"/>
+          </a:xfrm>
+          <a:prstGeom prst="rect">
+            <a:avLst/>
+          </a:prstGeom>
+          <a:noFill/>
+          <a:ln/>
+        </p:spPr>
+        <p:txBody>
+          <a:bodyPr wrap="square" lIns="0" tIns="0" rIns="0" bIns="0" rtlCol="0" anchor="ctr"/>
+          <a:lstStyle/>
+          <a:p>
+            <a:pPr indent="0" marL="0">
+              <a:buNone/>
+            </a:pPr>
+            <a:r>
+              <a:rPr lang="en-US" sz="1100" spc="300" kern="0" dirty="0">
+                <a:solidFill>
+                  <a:srgbClr val="6D28D9"/>
+                </a:solidFill>
+                <a:latin typeface="Courier New" pitchFamily="34" charset="0"/>
+                <a:ea typeface="Courier New" pitchFamily="34" charset="-122"/>
+                <a:cs typeface="Courier New" pitchFamily="34" charset="-120"/>
+              </a:rPr>
+              <a:t>SETUP · THE ONLY HARD SYNC POINT</a:t>
+            </a:r>
+            <a:endParaRPr lang="en-US" sz="1100" dirty="0"/>
+          </a:p>
+        </p:txBody>
+      </p:sp>
+      <p:sp>
+        <p:nvSpPr>
+          <p:cNvPr id="3" name="Text 1"/>
+          <p:cNvSpPr/>
+          <p:nvPr/>
+        </p:nvSpPr>
+        <p:spPr>
+          <a:xfrm>
+            <a:off x="502920" y="530352"/>
+            <a:ext cx="8138160" cy="685800"/>
+          </a:xfrm>
+          <a:prstGeom prst="rect">
+            <a:avLst/>
+          </a:prstGeom>
+          <a:noFill/>
+          <a:ln/>
+        </p:spPr>
+        <p:txBody>
+          <a:bodyPr wrap="square" lIns="0" tIns="0" rIns="0" bIns="0" rtlCol="0" anchor="ctr"/>
+          <a:lstStyle/>
+          <a:p>
+            <a:pPr indent="0" marL="0">
+              <a:buNone/>
+            </a:pPr>
+            <a:r>
+              <a:rPr lang="en-US" sz="3000" b="1" dirty="0">
+                <a:solidFill>
+                  <a:srgbClr val="2A1B3D"/>
+                </a:solidFill>
+                <a:latin typeface="Cambria" pitchFamily="34" charset="0"/>
+                <a:ea typeface="Cambria" pitchFamily="34" charset="-122"/>
+                <a:cs typeface="Cambria" pitchFamily="34" charset="-120"/>
+              </a:rPr>
+              <a:t>Your key, your budget, your brain</a:t>
+            </a:r>
+            <a:endParaRPr lang="en-US" sz="3000" dirty="0"/>
+          </a:p>
+        </p:txBody>
+      </p:sp>
+      <p:sp>
+        <p:nvSpPr>
+          <p:cNvPr id="4" name="Shape 2"/>
+          <p:cNvSpPr/>
+          <p:nvPr/>
+        </p:nvSpPr>
+        <p:spPr>
+          <a:xfrm>
+            <a:off x="502920" y="1417320"/>
+            <a:ext cx="3931920" cy="1463040"/>
+          </a:xfrm>
+          <a:prstGeom prst="roundRect">
+            <a:avLst>
+              <a:gd name="adj" fmla="val 5000"/>
+            </a:avLst>
+          </a:prstGeom>
+          <a:solidFill>
+            <a:srgbClr val="FFFFFF"/>
+          </a:solidFill>
+          <a:ln w="12700">
+            <a:solidFill>
+              <a:srgbClr val="E4DCF5"/>
+            </a:solidFill>
+            <a:prstDash val="solid"/>
+          </a:ln>
+          <a:effectLst>
+            <a:outerShdw sx="100000" sy="100000" kx="0" ky="0" algn="bl" rotWithShape="0" blurRad="88900" dist="25400" dir="5400000">
+              <a:srgbClr val="3A2A55">
+                <a:alpha val="14000"/>
+              </a:srgbClr>
+            </a:outerShdw>
+          </a:effectLst>
+        </p:spPr>
+      </p:sp>
+      <p:sp>
+        <p:nvSpPr>
+          <p:cNvPr id="5" name="Text 3"/>
+          <p:cNvSpPr/>
+          <p:nvPr/>
+        </p:nvSpPr>
+        <p:spPr>
+          <a:xfrm>
+            <a:off x="731520" y="1545336"/>
+            <a:ext cx="2103120" cy="365760"/>
+          </a:xfrm>
+          <a:prstGeom prst="rect">
+            <a:avLst/>
+          </a:prstGeom>
+          <a:noFill/>
+          <a:ln/>
+        </p:spPr>
+        <p:txBody>
+          <a:bodyPr wrap="square" lIns="0" tIns="0" rIns="0" bIns="0" rtlCol="0" anchor="ctr"/>
+          <a:lstStyle/>
+          <a:p>
+            <a:pPr indent="0" marL="0">
+              <a:buNone/>
+            </a:pPr>
+            <a:r>
+              <a:rPr lang="en-US" sz="1600" b="1" dirty="0">
+                <a:solidFill>
+                  <a:srgbClr val="2A1B3D"/>
+                </a:solidFill>
+                <a:latin typeface="Courier New" pitchFamily="34" charset="0"/>
+                <a:ea typeface="Courier New" pitchFamily="34" charset="-122"/>
+                <a:cs typeface="Courier New" pitchFamily="34" charset="-120"/>
+              </a:rPr>
+              <a:t>.env file</a:t>
+            </a:r>
+            <a:endParaRPr lang="en-US" sz="1600" dirty="0"/>
+          </a:p>
+        </p:txBody>
+      </p:sp>
+      <p:sp>
+        <p:nvSpPr>
+          <p:cNvPr id="6" name="Shape 4"/>
+          <p:cNvSpPr/>
+          <p:nvPr/>
+        </p:nvSpPr>
+        <p:spPr>
+          <a:xfrm>
+            <a:off x="2743200" y="1572768"/>
+            <a:ext cx="1508760" cy="310896"/>
+          </a:xfrm>
+          <a:prstGeom prst="roundRect">
+            <a:avLst>
+              <a:gd name="adj" fmla="val 50000"/>
+            </a:avLst>
+          </a:prstGeom>
+          <a:solidFill>
+            <a:srgbClr val="F3EFFB"/>
+          </a:solidFill>
+          <a:ln w="12700">
+            <a:solidFill>
+              <a:srgbClr val="A78BFA"/>
+            </a:solidFill>
+            <a:prstDash val="solid"/>
+          </a:ln>
+        </p:spPr>
+      </p:sp>
+      <p:sp>
+        <p:nvSpPr>
+          <p:cNvPr id="7" name="Text 5"/>
+          <p:cNvSpPr/>
+          <p:nvPr/>
+        </p:nvSpPr>
+        <p:spPr>
+          <a:xfrm>
+            <a:off x="2743200" y="1572768"/>
+            <a:ext cx="1508760" cy="310896"/>
+          </a:xfrm>
+          <a:prstGeom prst="rect">
+            <a:avLst/>
+          </a:prstGeom>
+          <a:noFill/>
+          <a:ln/>
+        </p:spPr>
+        <p:txBody>
+          <a:bodyPr wrap="square" lIns="0" tIns="0" rIns="0" bIns="0" rtlCol="0" anchor="ctr"/>
+          <a:lstStyle/>
+          <a:p>
+            <a:pPr algn="ctr" indent="0" marL="0">
+              <a:buNone/>
+            </a:pPr>
+            <a:r>
+              <a:rPr lang="en-US" sz="850" dirty="0">
+                <a:solidFill>
+                  <a:srgbClr val="6D28D9"/>
+                </a:solidFill>
+                <a:latin typeface="Courier New" pitchFamily="34" charset="0"/>
+                <a:ea typeface="Courier New" pitchFamily="34" charset="-122"/>
+                <a:cs typeface="Courier New" pitchFamily="34" charset="-120"/>
+              </a:rPr>
+              <a:t>Upload</a:t>
+            </a:r>
+            <a:endParaRPr lang="en-US" sz="850" dirty="0"/>
+          </a:p>
+        </p:txBody>
+      </p:sp>
+      <p:sp>
+        <p:nvSpPr>
+          <p:cNvPr id="8" name="Text 6"/>
+          <p:cNvSpPr/>
+          <p:nvPr/>
+        </p:nvSpPr>
+        <p:spPr>
+          <a:xfrm>
+            <a:off x="731520" y="1929384"/>
+            <a:ext cx="3520440" cy="640080"/>
+          </a:xfrm>
+          <a:prstGeom prst="rect">
+            <a:avLst/>
+          </a:prstGeom>
+          <a:noFill/>
+          <a:ln/>
+        </p:spPr>
+        <p:txBody>
+          <a:bodyPr wrap="square" lIns="0" tIns="0" rIns="0" bIns="0" rtlCol="0" anchor="ctr"/>
+          <a:lstStyle/>
+          <a:p>
+            <a:pPr indent="0" marL="0">
+              <a:buNone/>
+            </a:pPr>
+            <a:r>
+              <a:rPr lang="en-US" sz="1050" dirty="0">
+                <a:solidFill>
+                  <a:srgbClr val="3F3F49"/>
+                </a:solidFill>
+                <a:latin typeface="Calibri" pitchFamily="34" charset="0"/>
+                <a:ea typeface="Calibri" pitchFamily="34" charset="-122"/>
+                <a:cs typeface="Calibri" pitchFamily="34" charset="-120"/>
+              </a:rPr>
+              <a:t>Drop a .env into the file sidebar. The notebook parses it — and picks up OPENAI_MODEL while it is there.</a:t>
+            </a:r>
+            <a:endParaRPr lang="en-US" sz="1050" dirty="0"/>
+          </a:p>
+        </p:txBody>
+      </p:sp>
+      <p:sp>
+        <p:nvSpPr>
+          <p:cNvPr id="9" name="Text 7"/>
+          <p:cNvSpPr/>
+          <p:nvPr/>
+        </p:nvSpPr>
+        <p:spPr>
+          <a:xfrm>
+            <a:off x="731520" y="2569464"/>
+            <a:ext cx="3520440" cy="256032"/>
+          </a:xfrm>
+          <a:prstGeom prst="rect">
+            <a:avLst/>
+          </a:prstGeom>
+          <a:noFill/>
+          <a:ln/>
+        </p:spPr>
+        <p:txBody>
+          <a:bodyPr wrap="square" lIns="0" tIns="0" rIns="0" bIns="0" rtlCol="0" anchor="ctr"/>
+          <a:lstStyle/>
+          <a:p>
+            <a:pPr indent="0" marL="0">
+              <a:buNone/>
+            </a:pPr>
+            <a:r>
+              <a:rPr lang="en-US" sz="850" dirty="0">
+                <a:solidFill>
+                  <a:srgbClr val="6D28D9"/>
+                </a:solidFill>
+                <a:latin typeface="Courier New" pitchFamily="34" charset="0"/>
+                <a:ea typeface="Courier New" pitchFamily="34" charset="-122"/>
+                <a:cs typeface="Courier New" pitchFamily="34" charset="-120"/>
+              </a:rPr>
+              <a:t>OPENAI_API_KEY=sk-…</a:t>
+            </a:r>
+            <a:endParaRPr lang="en-US" sz="850" dirty="0"/>
+          </a:p>
+        </p:txBody>
+      </p:sp>
+      <p:sp>
+        <p:nvSpPr>
+          <p:cNvPr id="10" name="Shape 8"/>
+          <p:cNvSpPr/>
+          <p:nvPr/>
+        </p:nvSpPr>
+        <p:spPr>
+          <a:xfrm>
+            <a:off x="4709160" y="1417320"/>
+            <a:ext cx="3931920" cy="1463040"/>
+          </a:xfrm>
+          <a:prstGeom prst="roundRect">
+            <a:avLst>
+              <a:gd name="adj" fmla="val 5000"/>
+            </a:avLst>
+          </a:prstGeom>
+          <a:solidFill>
+            <a:srgbClr val="FFFFFF"/>
+          </a:solidFill>
+          <a:ln w="12700">
+            <a:solidFill>
+              <a:srgbClr val="E4DCF5"/>
+            </a:solidFill>
+            <a:prstDash val="solid"/>
+          </a:ln>
+          <a:effectLst>
+            <a:outerShdw sx="100000" sy="100000" kx="0" ky="0" algn="bl" rotWithShape="0" blurRad="88900" dist="25400" dir="5400000">
+              <a:srgbClr val="3A2A55">
+                <a:alpha val="14000"/>
+              </a:srgbClr>
+            </a:outerShdw>
+          </a:effectLst>
+        </p:spPr>
+      </p:sp>
+      <p:sp>
+        <p:nvSpPr>
+          <p:cNvPr id="11" name="Text 9"/>
+          <p:cNvSpPr/>
+          <p:nvPr/>
+        </p:nvSpPr>
+        <p:spPr>
+          <a:xfrm>
+            <a:off x="4937760" y="1545336"/>
+            <a:ext cx="2103120" cy="365760"/>
+          </a:xfrm>
+          <a:prstGeom prst="rect">
+            <a:avLst/>
+          </a:prstGeom>
+          <a:noFill/>
+          <a:ln/>
+        </p:spPr>
+        <p:txBody>
+          <a:bodyPr wrap="square" lIns="0" tIns="0" rIns="0" bIns="0" rtlCol="0" anchor="ctr"/>
+          <a:lstStyle/>
+          <a:p>
+            <a:pPr indent="0" marL="0">
+              <a:buNone/>
+            </a:pPr>
+            <a:r>
+              <a:rPr lang="en-US" sz="1600" b="1" dirty="0">
+                <a:solidFill>
+                  <a:srgbClr val="2A1B3D"/>
+                </a:solidFill>
+                <a:latin typeface="Courier New" pitchFamily="34" charset="0"/>
+                <a:ea typeface="Courier New" pitchFamily="34" charset="-122"/>
+                <a:cs typeface="Courier New" pitchFamily="34" charset="-120"/>
+              </a:rPr>
+              <a:t>Colab Secrets</a:t>
+            </a:r>
+            <a:endParaRPr lang="en-US" sz="1600" dirty="0"/>
+          </a:p>
+        </p:txBody>
+      </p:sp>
+      <p:sp>
+        <p:nvSpPr>
+          <p:cNvPr id="12" name="Shape 10"/>
+          <p:cNvSpPr/>
+          <p:nvPr/>
+        </p:nvSpPr>
+        <p:spPr>
+          <a:xfrm>
+            <a:off x="6949440" y="1572768"/>
+            <a:ext cx="1508760" cy="310896"/>
+          </a:xfrm>
+          <a:prstGeom prst="roundRect">
+            <a:avLst>
+              <a:gd name="adj" fmla="val 50000"/>
+            </a:avLst>
+          </a:prstGeom>
+          <a:solidFill>
+            <a:srgbClr val="F3EFFB"/>
+          </a:solidFill>
+          <a:ln w="12700">
+            <a:solidFill>
+              <a:srgbClr val="A78BFA"/>
+            </a:solidFill>
+            <a:prstDash val="solid"/>
+          </a:ln>
+        </p:spPr>
+      </p:sp>
+      <p:sp>
+        <p:nvSpPr>
+          <p:cNvPr id="13" name="Text 11"/>
+          <p:cNvSpPr/>
+          <p:nvPr/>
+        </p:nvSpPr>
+        <p:spPr>
+          <a:xfrm>
+            <a:off x="6949440" y="1572768"/>
+            <a:ext cx="1508760" cy="310896"/>
+          </a:xfrm>
+          <a:prstGeom prst="rect">
+            <a:avLst/>
+          </a:prstGeom>
+          <a:noFill/>
+          <a:ln/>
+        </p:spPr>
+        <p:txBody>
+          <a:bodyPr wrap="square" lIns="0" tIns="0" rIns="0" bIns="0" rtlCol="0" anchor="ctr"/>
+          <a:lstStyle/>
+          <a:p>
+            <a:pPr algn="ctr" indent="0" marL="0">
+              <a:buNone/>
+            </a:pPr>
+            <a:r>
+              <a:rPr lang="en-US" sz="850" dirty="0">
+                <a:solidFill>
+                  <a:srgbClr val="6D28D9"/>
+                </a:solidFill>
+                <a:latin typeface="Courier New" pitchFamily="34" charset="0"/>
+                <a:ea typeface="Courier New" pitchFamily="34" charset="-122"/>
+                <a:cs typeface="Courier New" pitchFamily="34" charset="-120"/>
+              </a:rPr>
+              <a:t>Recommended</a:t>
+            </a:r>
+            <a:endParaRPr lang="en-US" sz="850" dirty="0"/>
+          </a:p>
+        </p:txBody>
+      </p:sp>
+      <p:sp>
+        <p:nvSpPr>
+          <p:cNvPr id="14" name="Text 12"/>
+          <p:cNvSpPr/>
+          <p:nvPr/>
+        </p:nvSpPr>
+        <p:spPr>
+          <a:xfrm>
+            <a:off x="4937760" y="1929384"/>
+            <a:ext cx="3520440" cy="640080"/>
+          </a:xfrm>
+          <a:prstGeom prst="rect">
+            <a:avLst/>
+          </a:prstGeom>
+          <a:noFill/>
+          <a:ln/>
+        </p:spPr>
+        <p:txBody>
+          <a:bodyPr wrap="square" lIns="0" tIns="0" rIns="0" bIns="0" rtlCol="0" anchor="ctr"/>
+          <a:lstStyle/>
+          <a:p>
+            <a:pPr indent="0" marL="0">
+              <a:buNone/>
+            </a:pPr>
+            <a:r>
+              <a:rPr lang="en-US" sz="1050" dirty="0">
+                <a:solidFill>
+                  <a:srgbClr val="3F3F49"/>
+                </a:solidFill>
+                <a:latin typeface="Calibri" pitchFamily="34" charset="0"/>
+                <a:ea typeface="Calibri" pitchFamily="34" charset="-122"/>
+                <a:cs typeface="Calibri" pitchFamily="34" charset="-120"/>
+              </a:rPr>
+              <a:t>The 🔑 icon, left sidebar. Add the key, enable notebook access. It never lands in the file you share.</a:t>
+            </a:r>
+            <a:endParaRPr lang="en-US" sz="1050" dirty="0"/>
+          </a:p>
+        </p:txBody>
+      </p:sp>
+      <p:sp>
+        <p:nvSpPr>
+          <p:cNvPr id="15" name="Text 13"/>
+          <p:cNvSpPr/>
+          <p:nvPr/>
+        </p:nvSpPr>
+        <p:spPr>
+          <a:xfrm>
+            <a:off x="4937760" y="2569464"/>
+            <a:ext cx="3520440" cy="256032"/>
+          </a:xfrm>
+          <a:prstGeom prst="rect">
+            <a:avLst/>
+          </a:prstGeom>
+          <a:noFill/>
+          <a:ln/>
+        </p:spPr>
+        <p:txBody>
+          <a:bodyPr wrap="square" lIns="0" tIns="0" rIns="0" bIns="0" rtlCol="0" anchor="ctr"/>
+          <a:lstStyle/>
+          <a:p>
+            <a:pPr indent="0" marL="0">
+              <a:buNone/>
+            </a:pPr>
+            <a:r>
+              <a:rPr lang="en-US" sz="850" dirty="0">
+                <a:solidFill>
+                  <a:srgbClr val="6D28D9"/>
+                </a:solidFill>
+                <a:latin typeface="Courier New" pitchFamily="34" charset="0"/>
+                <a:ea typeface="Courier New" pitchFamily="34" charset="-122"/>
+                <a:cs typeface="Courier New" pitchFamily="34" charset="-120"/>
+              </a:rPr>
+              <a:t>userdata.get("OPENAI_API_KEY")</a:t>
+            </a:r>
+            <a:endParaRPr lang="en-US" sz="850" dirty="0"/>
+          </a:p>
+        </p:txBody>
+      </p:sp>
+      <p:sp>
+        <p:nvSpPr>
+          <p:cNvPr id="16" name="Shape 14"/>
+          <p:cNvSpPr/>
+          <p:nvPr/>
+        </p:nvSpPr>
+        <p:spPr>
+          <a:xfrm>
+            <a:off x="502920" y="3044952"/>
+            <a:ext cx="3931920" cy="1463040"/>
+          </a:xfrm>
+          <a:prstGeom prst="roundRect">
+            <a:avLst>
+              <a:gd name="adj" fmla="val 5000"/>
+            </a:avLst>
+          </a:prstGeom>
+          <a:solidFill>
+            <a:srgbClr val="F3EFFB"/>
+          </a:solidFill>
+          <a:ln w="12700">
+            <a:solidFill>
+              <a:srgbClr val="E4DCF5"/>
+            </a:solidFill>
+            <a:prstDash val="solid"/>
+          </a:ln>
+          <a:effectLst>
+            <a:outerShdw sx="100000" sy="100000" kx="0" ky="0" algn="bl" rotWithShape="0" blurRad="88900" dist="25400" dir="5400000">
+              <a:srgbClr val="3A2A55">
+                <a:alpha val="14000"/>
+              </a:srgbClr>
+            </a:outerShdw>
+          </a:effectLst>
+        </p:spPr>
+      </p:sp>
+      <p:sp>
+        <p:nvSpPr>
+          <p:cNvPr id="17" name="Text 15"/>
+          <p:cNvSpPr/>
+          <p:nvPr/>
+        </p:nvSpPr>
+        <p:spPr>
+          <a:xfrm>
+            <a:off x="731520" y="3172968"/>
+            <a:ext cx="2103120" cy="365760"/>
+          </a:xfrm>
+          <a:prstGeom prst="rect">
+            <a:avLst/>
+          </a:prstGeom>
+          <a:noFill/>
+          <a:ln/>
+        </p:spPr>
+        <p:txBody>
+          <a:bodyPr wrap="square" lIns="0" tIns="0" rIns="0" bIns="0" rtlCol="0" anchor="ctr"/>
+          <a:lstStyle/>
+          <a:p>
+            <a:pPr indent="0" marL="0">
+              <a:buNone/>
+            </a:pPr>
+            <a:r>
+              <a:rPr lang="en-US" sz="1600" b="1" dirty="0">
+                <a:solidFill>
+                  <a:srgbClr val="2A1B3D"/>
+                </a:solidFill>
+                <a:latin typeface="Courier New" pitchFamily="34" charset="0"/>
+                <a:ea typeface="Courier New" pitchFamily="34" charset="-122"/>
+                <a:cs typeface="Courier New" pitchFamily="34" charset="-120"/>
+              </a:rPr>
+              <a:t>Hidden prompt</a:t>
+            </a:r>
+            <a:endParaRPr lang="en-US" sz="1600" dirty="0"/>
+          </a:p>
+        </p:txBody>
+      </p:sp>
+      <p:sp>
+        <p:nvSpPr>
+          <p:cNvPr id="18" name="Shape 16"/>
+          <p:cNvSpPr/>
+          <p:nvPr/>
+        </p:nvSpPr>
+        <p:spPr>
+          <a:xfrm>
+            <a:off x="2743200" y="3200400"/>
+            <a:ext cx="1508760" cy="310896"/>
+          </a:xfrm>
+          <a:prstGeom prst="roundRect">
+            <a:avLst>
+              <a:gd name="adj" fmla="val 50000"/>
+            </a:avLst>
+          </a:prstGeom>
+          <a:solidFill>
+            <a:srgbClr val="F3EFFB"/>
+          </a:solidFill>
+          <a:ln w="12700">
+            <a:solidFill>
+              <a:srgbClr val="A78BFA"/>
+            </a:solidFill>
+            <a:prstDash val="solid"/>
+          </a:ln>
+        </p:spPr>
+      </p:sp>
+      <p:sp>
+        <p:nvSpPr>
+          <p:cNvPr id="19" name="Text 17"/>
+          <p:cNvSpPr/>
+          <p:nvPr/>
+        </p:nvSpPr>
+        <p:spPr>
+          <a:xfrm>
+            <a:off x="2743200" y="3200400"/>
+            <a:ext cx="1508760" cy="310896"/>
+          </a:xfrm>
+          <a:prstGeom prst="rect">
+            <a:avLst/>
+          </a:prstGeom>
+          <a:noFill/>
+          <a:ln/>
+        </p:spPr>
+        <p:txBody>
+          <a:bodyPr wrap="square" lIns="0" tIns="0" rIns="0" bIns="0" rtlCol="0" anchor="ctr"/>
+          <a:lstStyle/>
+          <a:p>
+            <a:pPr algn="ctr" indent="0" marL="0">
+              <a:buNone/>
+            </a:pPr>
+            <a:r>
+              <a:rPr lang="en-US" sz="850" dirty="0">
+                <a:solidFill>
+                  <a:srgbClr val="6D28D9"/>
+                </a:solidFill>
+                <a:latin typeface="Courier New" pitchFamily="34" charset="0"/>
+                <a:ea typeface="Courier New" pitchFamily="34" charset="-122"/>
+                <a:cs typeface="Courier New" pitchFamily="34" charset="-120"/>
+              </a:rPr>
+              <a:t>Fallback</a:t>
+            </a:r>
+            <a:endParaRPr lang="en-US" sz="850" dirty="0"/>
+          </a:p>
+        </p:txBody>
+      </p:sp>
+      <p:sp>
+        <p:nvSpPr>
+          <p:cNvPr id="20" name="Text 18"/>
+          <p:cNvSpPr/>
+          <p:nvPr/>
+        </p:nvSpPr>
+        <p:spPr>
+          <a:xfrm>
+            <a:off x="731520" y="3557016"/>
+            <a:ext cx="3520440" cy="640080"/>
+          </a:xfrm>
+          <a:prstGeom prst="rect">
+            <a:avLst/>
+          </a:prstGeom>
+          <a:noFill/>
+          <a:ln/>
+        </p:spPr>
+        <p:txBody>
+          <a:bodyPr wrap="square" lIns="0" tIns="0" rIns="0" bIns="0" rtlCol="0" anchor="ctr"/>
+          <a:lstStyle/>
+          <a:p>
+            <a:pPr indent="0" marL="0">
+              <a:buNone/>
+            </a:pPr>
+            <a:r>
+              <a:rPr lang="en-US" sz="1050" dirty="0">
+                <a:solidFill>
+                  <a:srgbClr val="3F3F49"/>
+                </a:solidFill>
+                <a:latin typeface="Calibri" pitchFamily="34" charset="0"/>
+                <a:ea typeface="Calibri" pitchFamily="34" charset="-122"/>
+                <a:cs typeface="Calibri" pitchFamily="34" charset="-120"/>
+              </a:rPr>
+              <a:t>No file, no secret? The notebook asks, with the input masked. Never paste a key into a code cell.</a:t>
+            </a:r>
+            <a:endParaRPr lang="en-US" sz="1050" dirty="0"/>
+          </a:p>
+        </p:txBody>
+      </p:sp>
+      <p:sp>
+        <p:nvSpPr>
+          <p:cNvPr id="21" name="Text 19"/>
+          <p:cNvSpPr/>
+          <p:nvPr/>
+        </p:nvSpPr>
+        <p:spPr>
+          <a:xfrm>
+            <a:off x="731520" y="4197096"/>
+            <a:ext cx="3520440" cy="256032"/>
+          </a:xfrm>
+          <a:prstGeom prst="rect">
+            <a:avLst/>
+          </a:prstGeom>
+          <a:noFill/>
+          <a:ln/>
+        </p:spPr>
+        <p:txBody>
+          <a:bodyPr wrap="square" lIns="0" tIns="0" rIns="0" bIns="0" rtlCol="0" anchor="ctr"/>
+          <a:lstStyle/>
+          <a:p>
+            <a:pPr indent="0" marL="0">
+              <a:buNone/>
+            </a:pPr>
+            <a:r>
+              <a:rPr lang="en-US" sz="850" dirty="0">
+                <a:solidFill>
+                  <a:srgbClr val="6D28D9"/>
+                </a:solidFill>
+                <a:latin typeface="Courier New" pitchFamily="34" charset="0"/>
+                <a:ea typeface="Courier New" pitchFamily="34" charset="-122"/>
+                <a:cs typeface="Courier New" pitchFamily="34" charset="-120"/>
+              </a:rPr>
+              <a:t>getpass.getpass()</a:t>
+            </a:r>
+            <a:endParaRPr lang="en-US" sz="850" dirty="0"/>
+          </a:p>
+        </p:txBody>
+      </p:sp>
+      <p:sp>
+        <p:nvSpPr>
+          <p:cNvPr id="22" name="Shape 20"/>
+          <p:cNvSpPr/>
+          <p:nvPr/>
+        </p:nvSpPr>
+        <p:spPr>
+          <a:xfrm>
+            <a:off x="4709160" y="3044952"/>
+            <a:ext cx="3931920" cy="1463040"/>
+          </a:xfrm>
+          <a:prstGeom prst="roundRect">
+            <a:avLst>
+              <a:gd name="adj" fmla="val 5000"/>
+            </a:avLst>
+          </a:prstGeom>
+          <a:solidFill>
+            <a:srgbClr val="F3EFFB"/>
+          </a:solidFill>
+          <a:ln w="12700">
+            <a:solidFill>
+              <a:srgbClr val="E4DCF5"/>
+            </a:solidFill>
+            <a:prstDash val="solid"/>
+          </a:ln>
+          <a:effectLst>
+            <a:outerShdw sx="100000" sy="100000" kx="0" ky="0" algn="bl" rotWithShape="0" blurRad="88900" dist="25400" dir="5400000">
+              <a:srgbClr val="3A2A55">
+                <a:alpha val="14000"/>
+              </a:srgbClr>
+            </a:outerShdw>
+          </a:effectLst>
+        </p:spPr>
+      </p:sp>
+      <p:sp>
+        <p:nvSpPr>
+          <p:cNvPr id="23" name="Text 21"/>
+          <p:cNvSpPr/>
+          <p:nvPr/>
+        </p:nvSpPr>
+        <p:spPr>
+          <a:xfrm>
+            <a:off x="4937760" y="3172968"/>
+            <a:ext cx="2103120" cy="365760"/>
+          </a:xfrm>
+          <a:prstGeom prst="rect">
+            <a:avLst/>
+          </a:prstGeom>
+          <a:noFill/>
+          <a:ln/>
+        </p:spPr>
+        <p:txBody>
+          <a:bodyPr wrap="square" lIns="0" tIns="0" rIns="0" bIns="0" rtlCol="0" anchor="ctr"/>
+          <a:lstStyle/>
+          <a:p>
+            <a:pPr indent="0" marL="0">
+              <a:buNone/>
+            </a:pPr>
+            <a:r>
+              <a:rPr lang="en-US" sz="1600" b="1" dirty="0">
+                <a:solidFill>
+                  <a:srgbClr val="2A1B3D"/>
+                </a:solidFill>
+                <a:latin typeface="Courier New" pitchFamily="34" charset="0"/>
+                <a:ea typeface="Courier New" pitchFamily="34" charset="-122"/>
+                <a:cs typeface="Courier New" pitchFamily="34" charset="-120"/>
+              </a:rPr>
+              <a:t>The cost meter</a:t>
+            </a:r>
+            <a:endParaRPr lang="en-US" sz="1600" dirty="0"/>
+          </a:p>
+        </p:txBody>
+      </p:sp>
+      <p:sp>
+        <p:nvSpPr>
+          <p:cNvPr id="24" name="Shape 22"/>
+          <p:cNvSpPr/>
+          <p:nvPr/>
+        </p:nvSpPr>
+        <p:spPr>
+          <a:xfrm>
+            <a:off x="6949440" y="3200400"/>
+            <a:ext cx="1508760" cy="310896"/>
+          </a:xfrm>
+          <a:prstGeom prst="roundRect">
+            <a:avLst>
+              <a:gd name="adj" fmla="val 50000"/>
+            </a:avLst>
+          </a:prstGeom>
+          <a:solidFill>
+            <a:srgbClr val="F3EFFB"/>
+          </a:solidFill>
+          <a:ln w="12700">
+            <a:solidFill>
+              <a:srgbClr val="A78BFA"/>
+            </a:solidFill>
+            <a:prstDash val="solid"/>
+          </a:ln>
+        </p:spPr>
+      </p:sp>
+      <p:sp>
+        <p:nvSpPr>
+          <p:cNvPr id="25" name="Text 23"/>
+          <p:cNvSpPr/>
+          <p:nvPr/>
+        </p:nvSpPr>
+        <p:spPr>
+          <a:xfrm>
+            <a:off x="6949440" y="3200400"/>
+            <a:ext cx="1508760" cy="310896"/>
+          </a:xfrm>
+          <a:prstGeom prst="rect">
+            <a:avLst/>
+          </a:prstGeom>
+          <a:noFill/>
+          <a:ln/>
+        </p:spPr>
+        <p:txBody>
+          <a:bodyPr wrap="square" lIns="0" tIns="0" rIns="0" bIns="0" rtlCol="0" anchor="ctr"/>
+          <a:lstStyle/>
+          <a:p>
+            <a:pPr algn="ctr" indent="0" marL="0">
+              <a:buNone/>
+            </a:pPr>
+            <a:r>
+              <a:rPr lang="en-US" sz="850" dirty="0">
+                <a:solidFill>
+                  <a:srgbClr val="6D28D9"/>
+                </a:solidFill>
+                <a:latin typeface="Courier New" pitchFamily="34" charset="0"/>
+                <a:ea typeface="Courier New" pitchFamily="34" charset="-122"/>
+                <a:cs typeface="Courier New" pitchFamily="34" charset="-120"/>
+              </a:rPr>
+              <a:t>Budget</a:t>
+            </a:r>
+            <a:endParaRPr lang="en-US" sz="850" dirty="0"/>
+          </a:p>
+        </p:txBody>
+      </p:sp>
+      <p:sp>
+        <p:nvSpPr>
+          <p:cNvPr id="26" name="Text 24"/>
+          <p:cNvSpPr/>
+          <p:nvPr/>
+        </p:nvSpPr>
+        <p:spPr>
+          <a:xfrm>
+            <a:off x="4937760" y="3557016"/>
+            <a:ext cx="3520440" cy="640080"/>
+          </a:xfrm>
+          <a:prstGeom prst="rect">
+            <a:avLst/>
+          </a:prstGeom>
+          <a:noFill/>
+          <a:ln/>
+        </p:spPr>
+        <p:txBody>
+          <a:bodyPr wrap="square" lIns="0" tIns="0" rIns="0" bIns="0" rtlCol="0" anchor="ctr"/>
+          <a:lstStyle/>
+          <a:p>
+            <a:pPr indent="0" marL="0">
+              <a:buNone/>
+            </a:pPr>
+            <a:r>
+              <a:rPr lang="en-US" sz="1050" dirty="0">
+                <a:solidFill>
+                  <a:srgbClr val="3F3F49"/>
+                </a:solidFill>
+                <a:latin typeface="Calibri" pitchFamily="34" charset="0"/>
+                <a:ea typeface="Calibri" pitchFamily="34" charset="-122"/>
+                <a:cs typeface="Calibri" pitchFamily="34" charset="-120"/>
+              </a:rPr>
+              <a:t>Every call is counted. The whole notebook costs roughly $0.05–0.25 on gpt-4.1-mini. Check any time.</a:t>
+            </a:r>
+            <a:endParaRPr lang="en-US" sz="1050" dirty="0"/>
+          </a:p>
+        </p:txBody>
+      </p:sp>
+      <p:sp>
+        <p:nvSpPr>
+          <p:cNvPr id="27" name="Text 25"/>
+          <p:cNvSpPr/>
+          <p:nvPr/>
+        </p:nvSpPr>
+        <p:spPr>
+          <a:xfrm>
+            <a:off x="4937760" y="4197096"/>
+            <a:ext cx="3520440" cy="256032"/>
+          </a:xfrm>
+          <a:prstGeom prst="rect">
+            <a:avLst/>
+          </a:prstGeom>
+          <a:noFill/>
+          <a:ln/>
+        </p:spPr>
+        <p:txBody>
+          <a:bodyPr wrap="square" lIns="0" tIns="0" rIns="0" bIns="0" rtlCol="0" anchor="ctr"/>
+          <a:lstStyle/>
+          <a:p>
+            <a:pPr indent="0" marL="0">
+              <a:buNone/>
+            </a:pPr>
+            <a:r>
+              <a:rPr lang="en-US" sz="850" dirty="0">
+                <a:solidFill>
+                  <a:srgbClr val="6D28D9"/>
+                </a:solidFill>
+                <a:latin typeface="Courier New" pitchFamily="34" charset="0"/>
+                <a:ea typeface="Courier New" pitchFamily="34" charset="-122"/>
+                <a:cs typeface="Courier New" pitchFamily="34" charset="-120"/>
+              </a:rPr>
+              <a:t>cost_report()</a:t>
+            </a:r>
+            <a:endParaRPr lang="en-US" sz="850" dirty="0"/>
+          </a:p>
+        </p:txBody>
+      </p:sp>
+      <p:sp>
+        <p:nvSpPr>
+          <p:cNvPr id="28" name="Text 26"/>
+          <p:cNvSpPr/>
+          <p:nvPr/>
+        </p:nvSpPr>
+        <p:spPr>
+          <a:xfrm>
+            <a:off x="502920" y="4709160"/>
+            <a:ext cx="8138160" cy="320040"/>
+          </a:xfrm>
+          <a:prstGeom prst="rect">
+            <a:avLst/>
+          </a:prstGeom>
+          <a:noFill/>
+          <a:ln/>
+        </p:spPr>
+        <p:txBody>
+          <a:bodyPr wrap="square" lIns="0" tIns="0" rIns="0" bIns="0" rtlCol="0" anchor="ctr"/>
+          <a:lstStyle/>
+          <a:p>
+            <a:pPr algn="ctr" indent="0" marL="0">
+              <a:buNone/>
+            </a:pPr>
+            <a:r>
+              <a:rPr lang="en-US" sz="1400" i="1" dirty="0">
+                <a:solidFill>
+                  <a:srgbClr val="6D28D9"/>
+                </a:solidFill>
+                <a:latin typeface="Calibri" pitchFamily="34" charset="0"/>
+                <a:ea typeface="Calibri" pitchFamily="34" charset="-122"/>
+                <a:cs typeface="Calibri" pitchFamily="34" charset="-120"/>
+              </a:rPr>
+              <a:t>No GPU required. The brain is an API call — one llm() function that all six of today's agents go through.</a:t>
+            </a:r>
+            <a:endParaRPr lang="en-US" sz="1400" dirty="0"/>
           </a:p>
         </p:txBody>
       </p:sp>
@@ -9530,7 +10548,7 @@
                 <a:ea typeface="Courier New" pitchFamily="34" charset="-122"/>
                 <a:cs typeface="Courier New" pitchFamily="34" charset="-120"/>
               </a:rPr>
-              <a:t>15:00 – 16:00</a:t>
+              <a:t>15:15 – 16:05</a:t>
             </a:r>
             <a:endParaRPr lang="en-US" sz="1200" dirty="0"/>
           </a:p>
@@ -9569,7 +10587,7 @@
                 <a:ea typeface="Courier New" pitchFamily="34" charset="-122"/>
                 <a:cs typeface="Courier New" pitchFamily="34" charset="-120"/>
               </a:rPr>
-              <a:t>notebook · Part 1</a:t>
+              <a:t>one notebook · Part 1</a:t>
             </a:r>
             <a:endParaRPr lang="en-US" sz="950" dirty="0"/>
           </a:p>
@@ -9779,7 +10797,7 @@
                 <a:ea typeface="Courier New" pitchFamily="34" charset="-122"/>
                 <a:cs typeface="Courier New" pitchFamily="34" charset="-120"/>
               </a:rPr>
-              <a:t>16:05 – 17:15</a:t>
+              <a:t>16:10 – 17:15</a:t>
             </a:r>
             <a:endParaRPr lang="en-US" sz="1200" dirty="0"/>
           </a:p>
@@ -9818,7 +10836,7 @@
                 <a:ea typeface="Courier New" pitchFamily="34" charset="-122"/>
                 <a:cs typeface="Courier New" pitchFamily="34" charset="-120"/>
               </a:rPr>
-              <a:t>notebook · Part 2</a:t>
+              <a:t>one notebook · Part 2</a:t>
             </a:r>
             <a:endParaRPr lang="en-US" sz="950" dirty="0"/>
           </a:p>
@@ -10028,7 +11046,7 @@
                 <a:ea typeface="Courier New" pitchFamily="34" charset="-122"/>
                 <a:cs typeface="Courier New" pitchFamily="34" charset="-120"/>
               </a:rPr>
-              <a:t>17:20 – 18:00</a:t>
+              <a:t>17:20 – 17:55</a:t>
             </a:r>
             <a:endParaRPr lang="en-US" sz="1200" dirty="0"/>
           </a:p>
@@ -10067,7 +11085,7 @@
                 <a:ea typeface="Courier New" pitchFamily="34" charset="-122"/>
                 <a:cs typeface="Courier New" pitchFamily="34" charset="-120"/>
               </a:rPr>
-              <a:t>notebook · Part 3</a:t>
+              <a:t>one notebook · Part 3</a:t>
             </a:r>
             <a:endParaRPr lang="en-US" sz="950" dirty="0"/>
           </a:p>
@@ -10106,7 +11124,7 @@
                 <a:ea typeface="Courier New" pitchFamily="34" charset="-122"/>
                 <a:cs typeface="Courier New" pitchFamily="34" charset="-120"/>
               </a:rPr>
-              <a:t>Setup now: colab.research.google.com → open Part 1 → Runtime → Change runtime type → T4 GPU</a:t>
+              <a:t>Setup now: colab.research.google.com → upload the notebook → run Part 0. No GPU needed.</a:t>
             </a:r>
             <a:endParaRPr lang="en-US" sz="1050" dirty="0"/>
           </a:p>
@@ -12239,7 +13257,7 @@
                 <a:ea typeface="Courier New" pitchFamily="34" charset="-122"/>
                 <a:cs typeface="Courier New" pitchFamily="34" charset="-120"/>
               </a:rPr>
-              <a:t>github.com/KarthikShivasankar</a:t>
+              <a:t>pip install ml-code-smell-detector</a:t>
             </a:r>
             <a:endParaRPr lang="en-US" sz="850" dirty="0"/>
           </a:p>
@@ -12730,7 +13748,7 @@
                 <a:ea typeface="Calibri" pitchFamily="34" charset="-122"/>
                 <a:cs typeface="Calibri" pitchFamily="34" charset="-120"/>
               </a:rPr>
-              <a:t>Any LLM behind one function call. Today: Qwen2.5-Coder-1.5B — small enough for a free Colab T4.</a:t>
+              <a:t>Any LLM behind one function call. Today: the OpenAI API — change the model on line one, nothing else.</a:t>
             </a:r>
             <a:endParaRPr lang="en-US" sz="1080" dirty="0"/>
           </a:p>
@@ -13658,7 +14676,7 @@
                 <a:ea typeface="Calibri" pitchFamily="34" charset="-122"/>
                 <a:cs typeface="Calibri" pitchFamily="34" charset="-120"/>
               </a:rPr>
-              <a:t>This split is what lets a 1.5-billion-parameter model do useful engineering work.</a:t>
+              <a:t>This split is what makes an agent auditable: every claim traces back to a tool that measured it.</a:t>
             </a:r>
             <a:endParaRPr lang="en-US" sz="1400" dirty="0"/>
           </a:p>
@@ -13765,7 +14783,7 @@
                 <a:ea typeface="Courier New" pitchFamily="34" charset="-122"/>
                 <a:cs typeface="Courier New" pitchFamily="34" charset="-120"/>
               </a:rPr>
-              <a:t>HANDS-ON · NOTEBOOK PART 1</a:t>
+              <a:t>HANDS-ON · PART 1</a:t>
             </a:r>
             <a:endParaRPr lang="en-US" sz="1300" dirty="0"/>
           </a:p>
@@ -13889,7 +14907,7 @@
                 <a:ea typeface="Calibri" pitchFamily="34" charset="-122"/>
                 <a:cs typeface="Calibri" pitchFamily="34" charset="-120"/>
               </a:rPr>
-              <a:t>Load the 1.5B model, build the Agent class, run your first audit</a:t>
+              <a:t>One llm() helper, the Agent class, and your first structured JSON audit</a:t>
             </a:r>
             <a:endParaRPr lang="en-US" sz="1550" dirty="0"/>
           </a:p>
@@ -13997,7 +15015,7 @@
                 <a:ea typeface="Courier New" pitchFamily="34" charset="-122"/>
                 <a:cs typeface="Courier New" pitchFamily="34" charset="-120"/>
               </a:rPr>
-              <a:t>~45 MINUTES</a:t>
+              <a:t>~50 MINUTES</a:t>
             </a:r>
             <a:endParaRPr lang="en-US" sz="1050" dirty="0"/>
           </a:p>

</xml_diff>